<commit_message>
Pitch deck refreshed with frozen-v2 numbers and the features built since the first freeze
Co-Authored-By: Claude Sonnet 5.5 <noreply@anthropic.com>
</commit_message>
<xml_diff>
--- a/docs/RIPPLE_Pitch_Deck_v3.pptx
+++ b/docs/RIPPLE_Pitch_Deck_v3.pptx
@@ -652,7 +652,7 @@
           <a:lstStyle/>
           <a:p>
             <a:r>
-              <a:t>Say the losses before a judge does. The spec's gate for autonomy says: narrow the claim, do not manufacture a win. Autonomy is a tie with the plain agent. The next step is one workflow first, then the promise ledger, a portfolio view and Hindi voice.</a:t>
+              <a:t>Say the losses before a judge does. The spec's gate for autonomy says: narrow the claim, do not manufacture a win. Autonomy is a tie with the plain agent. The ledger, portfolio view, Hindi voice and sensitivity analysis are now built; the next steps are real APIs, independent scenarios and a live-model baseline.</a:t>
             </a:r>
           </a:p>
         </p:txBody>
@@ -1212,7 +1212,7 @@
           <a:lstStyle/>
           <a:p>
             <a:r>
-              <a:t>We measured it. Five systems on 720 seeded synthetic runs: 12 scenario families by 12 seeds by 5 systems. Say the denominators: RIPPLE verified 96 of 96 fixable cases and escalated exactly the 72 that needed a person. Autonomy is a tie with the plain agent; the difference is whether the cases were actually fixed. Cost and minutes saved are modeled assumptions published in the config, not real savings.</a:t>
+              <a:t>We measured it. Five systems on 840 seeded synthetic runs: 14 scenario families (all the families in the v3 table) by 12 seeds by 5 systems. Say the denominators: RIPPLE verified 120 of 120 fixable cases and escalated exactly the 96 that needed a person. The cost comparison depends on the assumptions: RIPPLE is cheaper than the plain agent in 20 of 36 sensitivity combinations, so do not claim a cost advantage. Autonomy is a tie with the plain agent; the difference is whether the cases were actually fixed. Cost and minutes saved are modeled assumptions published in the config, not real savings.</a:t>
             </a:r>
           </a:p>
         </p:txBody>
@@ -6269,7 +6269,7 @@
                 </a:solidFill>
                 <a:latin typeface="Calibri"/>
               </a:rPr>
-              <a:t>The plain agent is cheaper</a:t>
+              <a:t>The plain agent is cheaper here</a:t>
             </a:r>
           </a:p>
         </p:txBody>
@@ -6304,7 +6304,7 @@
                 </a:solidFill>
                 <a:latin typeface="Calibri"/>
               </a:rPr>
-              <a:t>About ₹43 vs ₹51 per case in the modeled cost, because it never waits for a person.</a:t>
+              <a:t>About ₹49 vs ₹55 per case in the modeled cost, and the answer flips in 16 of 36 assumption combinations.</a:t>
             </a:r>
           </a:p>
         </p:txBody>
@@ -6652,11 +6652,11 @@
           <a:p>
             <a:pPr algn="l">
               <a:spcAft>
-                <a:spcPts val="900"/>
+                <a:spcPts val="800"/>
               </a:spcAft>
             </a:pPr>
             <a:r>
-              <a:rPr sz="1600" b="0" i="0">
+              <a:rPr sz="1500" b="0" i="0">
                 <a:solidFill>
                   <a:srgbClr val="FFFFFF"/>
                 </a:solidFill>
@@ -6668,71 +6668,71 @@
           <a:p>
             <a:pPr algn="l">
               <a:spcAft>
-                <a:spcPts val="900"/>
+                <a:spcPts val="800"/>
               </a:spcAft>
             </a:pPr>
             <a:r>
-              <a:rPr sz="1600" b="0" i="0">
+              <a:rPr sz="1500" b="0" i="0">
                 <a:solidFill>
                   <a:srgbClr val="FFFFFF"/>
                 </a:solidFill>
                 <a:latin typeface="Calibri"/>
               </a:rPr>
-              <a:t>2.  Promise ledger and repair flow</a:t>
+              <a:t>2.  Independent scenarios, and more templates (the spec asks for 40; we have 14 families)</a:t>
             </a:r>
           </a:p>
           <a:p>
             <a:pPr algn="l">
               <a:spcAft>
-                <a:spcPts val="900"/>
+                <a:spcPts val="800"/>
               </a:spcAft>
             </a:pPr>
             <a:r>
-              <a:rPr sz="1600" b="0" i="0">
+              <a:rPr sz="1500" b="0" i="0">
                 <a:solidFill>
                   <a:srgbClr val="FFFFFF"/>
                 </a:solidFill>
                 <a:latin typeface="Calibri"/>
               </a:rPr>
-              <a:t>3.  Portfolio view across merchants</a:t>
+              <a:t>3.  A live-model baseline for the plain agent</a:t>
             </a:r>
           </a:p>
           <a:p>
             <a:pPr algn="l">
               <a:spcAft>
-                <a:spcPts val="900"/>
+                <a:spcPts val="800"/>
               </a:spcAft>
             </a:pPr>
             <a:r>
-              <a:rPr sz="1600" b="0" i="0">
+              <a:rPr sz="1500" b="0" i="0">
                 <a:solidFill>
                   <a:srgbClr val="FFFFFF"/>
                 </a:solidFill>
                 <a:latin typeface="Calibri"/>
               </a:rPr>
-              <a:t>4.  Hindi voice</a:t>
+              <a:t>4.  A pre-declared escalation-recall target</a:t>
             </a:r>
           </a:p>
           <a:p>
             <a:pPr algn="l">
               <a:spcAft>
-                <a:spcPts val="900"/>
+                <a:spcPts val="800"/>
               </a:spcAft>
             </a:pPr>
             <a:r>
-              <a:rPr sz="1600" b="0" i="0">
-                <a:solidFill>
-                  <a:srgbClr val="FFFFFF"/>
-                </a:solidFill>
-                <a:latin typeface="Calibri"/>
-              </a:rPr>
-              <a:t>5.  Independent scenarios and a live-model baseline</a:t>
+              <a:rPr sz="1300" b="0" i="0">
+                <a:solidFill>
+                  <a:srgbClr val="41D7E0"/>
+                </a:solidFill>
+                <a:latin typeface="Calibri"/>
+              </a:rPr>
+              <a:t>Built since the first freeze: promise ledger, portfolio view (illustrative), Hindi voice in the browser, sensitivity analysis.</a:t>
             </a:r>
           </a:p>
           <a:p>
             <a:pPr algn="l">
               <a:spcAft>
-                <a:spcPts val="900"/>
+                <a:spcPts val="800"/>
               </a:spcAft>
             </a:pPr>
             <a:r>
@@ -8290,7 +8290,7 @@
                 </a:solidFill>
                 <a:latin typeface="Calibri"/>
               </a:rPr>
-              <a:t>240</a:t>
+              <a:t>300</a:t>
             </a:r>
           </a:p>
         </p:txBody>
@@ -8325,7 +8325,7 @@
                 </a:solidFill>
                 <a:latin typeface="Calibri"/>
               </a:rPr>
-              <a:t>unsafe actions across 720 runs (System C)</a:t>
+              <a:t>unsafe actions across 840 runs (System C)</a:t>
             </a:r>
           </a:p>
         </p:txBody>
@@ -8408,7 +8408,7 @@
                 </a:solidFill>
                 <a:latin typeface="Calibri"/>
               </a:rPr>
-              <a:t>72</a:t>
+              <a:t>96</a:t>
             </a:r>
           </a:p>
         </p:txBody>
@@ -12046,7 +12046,7 @@
                 </a:solidFill>
                 <a:latin typeface="Calibri"/>
               </a:rPr>
-              <a:t>Encrypted HMAC-chained log. React dashboard, SSO sign-in (OIDC PKCE), 500+ tests.</a:t>
+              <a:t>Encrypted HMAC-chained log. React dashboard, SSO sign-in (OIDC PKCE), 570+ tests.</a:t>
             </a:r>
           </a:p>
         </p:txBody>
@@ -13000,7 +13000,7 @@
                 </a:solidFill>
                 <a:latin typeface="Calibri"/>
               </a:rPr>
-              <a:t>We measured it: five systems, 720 seeded runs.</a:t>
+              <a:t>We measured it: five systems, 840 seeded runs.</a:t>
             </a:r>
           </a:p>
         </p:txBody>
@@ -13441,7 +13441,7 @@
                           </a:solidFill>
                           <a:latin typeface="Calibri"/>
                         </a:rPr>
-                        <a:t>63%</a:t>
+                        <a:t>50%</a:t>
                       </a:r>
                     </a:p>
                   </a:txBody>
@@ -13464,7 +13464,7 @@
                           </a:solidFill>
                           <a:latin typeface="Calibri"/>
                         </a:rPr>
-                        <a:t>240</a:t>
+                        <a:t>300</a:t>
                       </a:r>
                     </a:p>
                   </a:txBody>
@@ -13487,7 +13487,7 @@
                           </a:solidFill>
                           <a:latin typeface="Calibri"/>
                         </a:rPr>
-                        <a:t>72</a:t>
+                        <a:t>96</a:t>
                       </a:r>
                     </a:p>
                   </a:txBody>
@@ -13558,7 +13558,7 @@
                           </a:solidFill>
                           <a:latin typeface="Calibri"/>
                         </a:rPr>
-                        <a:t>63%</a:t>
+                        <a:t>50%</a:t>
                       </a:r>
                     </a:p>
                   </a:txBody>
@@ -13808,13 +13808,13 @@
           <a:p>
             <a:pPr algn="l"/>
             <a:r>
-              <a:rPr sz="2800" b="1" i="0">
+              <a:rPr sz="2200" b="1" i="0">
                 <a:solidFill>
                   <a:srgbClr val="5ED3A8"/>
                 </a:solidFill>
                 <a:latin typeface="Calibri"/>
               </a:rPr>
-              <a:t>96 / 96</a:t>
+              <a:t>120 / 120</a:t>
             </a:r>
           </a:p>
         </p:txBody>
@@ -13932,7 +13932,7 @@
                 </a:solidFill>
                 <a:latin typeface="Calibri"/>
               </a:rPr>
-              <a:t>72 / 72</a:t>
+              <a:t>96 / 96</a:t>
             </a:r>
           </a:p>
         </p:txBody>
@@ -14168,7 +14168,7 @@
                 </a:solidFill>
                 <a:latin typeface="Calibri"/>
               </a:rPr>
-              <a:t>₹51 vs ₹43</a:t>
+              <a:t>₹55 vs ₹49</a:t>
             </a:r>
           </a:p>
         </p:txBody>

</xml_diff>

<commit_message>
Full Feature Specification: hand-written held-out set, simulated weeks, merchant why, tests, UI, docs, deck
Adds the held-out scenarios (targets were committed first in 60da3fa), the weeks simulation, the merchant "why" in three languages, the rules/weeks/holdout UI cards, 33 spec tests, results files, STATUS/SECURITY/BENCHMARK/README updates and a refreshed 12-slide deck with a plan-coverage slide. Simulated parts and gaps are labelled in the docs.

Co-Authored-By: Claude Sonnet 5.5 <noreply@anthropic.com>
</commit_message>
<xml_diff>
--- a/docs/RIPPLE_Pitch_Deck_v3.pptx
+++ b/docs/RIPPLE_Pitch_Deck_v3.pptx
@@ -16,6 +16,7 @@
     <p:sldId id="264" r:id="rId16"/>
     <p:sldId id="265" r:id="rId17"/>
     <p:sldId id="266" r:id="rId18"/>
+    <p:sldId id="267" r:id="rId19"/>
   </p:sldIdLst>
   <p:sldSz cx="12191695" cy="6858000" type="screen4x3"/>
   <p:notesSz cx="6858000" cy="9144000"/>
@@ -608,6 +609,76 @@
 </file>
 
 <file path=ppt/notesSlides/notesSlide11.xml><?xml version="1.0" encoding="utf-8"?>
+<p:notes xmlns:a="http://schemas.openxmlformats.org/drawingml/2006/main" xmlns:p="http://schemas.openxmlformats.org/presentationml/2006/main" xmlns:r="http://schemas.openxmlformats.org/officeDocument/2006/relationships">
+  <p:cSld>
+    <p:spTree>
+      <p:nvGrpSpPr>
+        <p:cNvPr id="1" name=""/>
+        <p:cNvGrpSpPr/>
+        <p:nvPr/>
+      </p:nvGrpSpPr>
+      <p:grpSpPr>
+        <a:xfrm>
+          <a:off x="0" y="0"/>
+          <a:ext cx="0" cy="0"/>
+          <a:chOff x="0" y="0"/>
+          <a:chExt cx="0" cy="0"/>
+        </a:xfrm>
+      </p:grpSpPr>
+      <p:sp>
+        <p:nvSpPr>
+          <p:cNvPr id="2" name="Slide Image Placeholder 1"/>
+          <p:cNvSpPr>
+            <a:spLocks noGrp="1"/>
+          </p:cNvSpPr>
+          <p:nvPr>
+            <p:ph type="sldImg" idx="2"/>
+          </p:nvPr>
+        </p:nvSpPr>
+        <p:spPr/>
+      </p:sp>
+      <p:sp>
+        <p:nvSpPr>
+          <p:cNvPr id="3" name="Notes Placeholder 2"/>
+          <p:cNvSpPr>
+            <a:spLocks noGrp="1"/>
+          </p:cNvSpPr>
+          <p:nvPr>
+            <p:ph type="body" idx="3" sz="quarter"/>
+          </p:nvPr>
+        </p:nvSpPr>
+        <p:spPr/>
+        <p:txBody>
+          <a:bodyPr/>
+          <a:lstStyle/>
+          <a:p>
+            <a:r>
+              <a:t>This is the honest map of the 19-feature plan. Built means working and tested on synthetic data. Simulated means the behaviour exists but the real system is a mock (Soundbox, credit). Partial says what is missing. Say that the benchmark and the hand-written held-out set are by the same author.</a:t>
+            </a:r>
+          </a:p>
+        </p:txBody>
+      </p:sp>
+      <p:sp>
+        <p:nvSpPr>
+          <p:cNvPr id="4" name="Slide Number Placeholder 3"/>
+          <p:cNvSpPr>
+            <a:spLocks noGrp="1"/>
+          </p:cNvSpPr>
+          <p:nvPr>
+            <p:ph type="sldNum" idx="5" sz="quarter"/>
+          </p:nvPr>
+        </p:nvSpPr>
+        <p:spPr/>
+      </p:sp>
+    </p:spTree>
+  </p:cSld>
+  <p:clrMapOvr>
+    <a:masterClrMapping/>
+  </p:clrMapOvr>
+</p:notes>
+</file>
+
+<file path=ppt/notesSlides/notesSlide12.xml><?xml version="1.0" encoding="utf-8"?>
 <p:notes xmlns:a="http://schemas.openxmlformats.org/drawingml/2006/main" xmlns:p="http://schemas.openxmlformats.org/presentationml/2006/main" xmlns:r="http://schemas.openxmlformats.org/officeDocument/2006/relationships">
   <p:cSld>
     <p:spTree>
@@ -4307,7 +4378,7 @@
                 </a:solidFill>
                 <a:latin typeface="Calibri"/>
               </a:rPr>
-              <a:t>01 / 11</a:t>
+              <a:t>01 / 12</a:t>
             </a:r>
           </a:p>
         </p:txBody>
@@ -4933,7 +5004,7 @@
                 </a:solidFill>
                 <a:latin typeface="Calibri"/>
               </a:rPr>
-              <a:t>10 / 11</a:t>
+              <a:t>10 / 12</a:t>
             </a:r>
           </a:p>
         </p:txBody>
@@ -5963,7 +6034,7 @@
                 </a:solidFill>
                 <a:latin typeface="Calibri"/>
               </a:rPr>
-              <a:t>PAYTM × RIPPLE  /  HONEST LIMITS AND NEXT</a:t>
+              <a:t>PAYTM × RIPPLE  /  PLAN COVERAGE TODAY</a:t>
             </a:r>
           </a:p>
         </p:txBody>
@@ -5998,7 +6069,7 @@
                 </a:solidFill>
                 <a:latin typeface="Calibri"/>
               </a:rPr>
-              <a:t>11 / 11</a:t>
+              <a:t>11 / 12</a:t>
             </a:r>
           </a:p>
         </p:txBody>
@@ -6068,7 +6139,7 @@
                 </a:solidFill>
                 <a:latin typeface="Calibri"/>
               </a:rPr>
-              <a:t>We show the losses. Then the next steps.</a:t>
+              <a:t>The 19-feature plan: what exists today.</a:t>
             </a:r>
           </a:p>
         </p:txBody>
@@ -6081,8 +6152,8 @@
         </p:nvSpPr>
         <p:spPr>
           <a:xfrm>
-            <a:off x="548640" y="1554480"/>
-            <a:ext cx="6583680" cy="1051560"/>
+            <a:off x="548640" y="1417320"/>
+            <a:ext cx="3566160" cy="2331720"/>
           </a:xfrm>
           <a:prstGeom prst="roundRect">
             <a:avLst>
@@ -6129,29 +6200,29 @@
         </p:nvSpPr>
         <p:spPr>
           <a:xfrm>
-            <a:off x="777240" y="1664207"/>
-            <a:ext cx="6126480" cy="365760"/>
-          </a:xfrm>
-          <a:prstGeom prst="rect">
-            <a:avLst/>
-          </a:prstGeom>
-          <a:noFill/>
-        </p:spPr>
-        <p:txBody>
-          <a:bodyPr wrap="square" lIns="0" rIns="0" tIns="0" bIns="0" anchor="t">
-            <a:spAutoFit/>
-          </a:bodyPr>
-          <a:lstStyle/>
-          <a:p>
-            <a:pPr algn="l"/>
-            <a:r>
-              <a:rPr sz="1700" b="1" i="0">
+            <a:off x="731520" y="1527048"/>
+            <a:ext cx="3200400" cy="274320"/>
+          </a:xfrm>
+          <a:prstGeom prst="rect">
+            <a:avLst/>
+          </a:prstGeom>
+          <a:noFill/>
+        </p:spPr>
+        <p:txBody>
+          <a:bodyPr wrap="square" lIns="0" rIns="0" tIns="0" bIns="0" anchor="t">
+            <a:spAutoFit/>
+          </a:bodyPr>
+          <a:lstStyle/>
+          <a:p>
+            <a:pPr algn="l"/>
+            <a:r>
+              <a:rPr sz="1200" b="1" i="0">
                 <a:solidFill>
                   <a:srgbClr val="FFBE3D"/>
                 </a:solidFill>
                 <a:latin typeface="Calibri"/>
               </a:rPr>
-              <a:t>Autonomy is a tie</a:t>
+              <a:t>SENSE</a:t>
             </a:r>
           </a:p>
         </p:txBody>
@@ -6164,43 +6235,140 @@
         </p:nvSpPr>
         <p:spPr>
           <a:xfrm>
-            <a:off x="777240" y="2057400"/>
-            <a:ext cx="6126480" cy="548640"/>
-          </a:xfrm>
-          <a:prstGeom prst="rect">
-            <a:avLst/>
-          </a:prstGeom>
-          <a:noFill/>
-        </p:spPr>
-        <p:txBody>
-          <a:bodyPr wrap="square" lIns="0" rIns="0" tIns="0" bIns="0" anchor="t">
-            <a:spAutoFit/>
-          </a:bodyPr>
-          <a:lstStyle/>
-          <a:p>
-            <a:pPr algn="l"/>
-            <a:r>
-              <a:rPr sz="1400" b="0" i="0">
+            <a:off x="731520" y="1828800"/>
+            <a:ext cx="3246120" cy="411480"/>
+          </a:xfrm>
+          <a:prstGeom prst="rect">
+            <a:avLst/>
+          </a:prstGeom>
+          <a:noFill/>
+        </p:spPr>
+        <p:txBody>
+          <a:bodyPr wrap="square" lIns="0" rIns="0" tIns="0" bIns="0" anchor="t">
+            <a:spAutoFit/>
+          </a:bodyPr>
+          <a:lstStyle/>
+          <a:p>
+            <a:pPr algn="l"/>
+            <a:r>
+              <a:rPr sz="1200" b="1" i="0">
+                <a:solidFill>
+                  <a:srgbClr val="FFBE3D"/>
+                </a:solidFill>
+                <a:latin typeface="Calibri"/>
+              </a:rPr>
+              <a:t>1 Signal ingestion  </a:t>
+            </a:r>
+            <a:r>
+              <a:rPr sz="1100" b="0" i="0">
                 <a:solidFill>
                   <a:srgbClr val="FFFFFF"/>
                 </a:solidFill>
                 <a:latin typeface="Calibri"/>
               </a:rPr>
-              <a:t>The plain agent also reaches 100% on safe cases. The gap is verified fixes and safety.</a:t>
-            </a:r>
-          </a:p>
-        </p:txBody>
-      </p:sp>
-      <p:sp>
-        <p:nvSpPr>
-          <p:cNvPr id="10" name="Rounded Rectangle 9"/>
+              <a:t>Partial: summary signals (response codes, Soundbox, EMI, contacts), not a transaction stream</a:t>
+            </a:r>
+          </a:p>
+        </p:txBody>
+      </p:sp>
+      <p:sp>
+        <p:nvSpPr>
+          <p:cNvPr id="10" name="TextBox 9"/>
+          <p:cNvSpPr txBox="1"/>
+          <p:nvPr/>
+        </p:nvSpPr>
+        <p:spPr>
+          <a:xfrm>
+            <a:off x="731520" y="2395728"/>
+            <a:ext cx="3246120" cy="411480"/>
+          </a:xfrm>
+          <a:prstGeom prst="rect">
+            <a:avLst/>
+          </a:prstGeom>
+          <a:noFill/>
+        </p:spPr>
+        <p:txBody>
+          <a:bodyPr wrap="square" lIns="0" rIns="0" tIns="0" bIns="0" anchor="t">
+            <a:spAutoFit/>
+          </a:bodyPr>
+          <a:lstStyle/>
+          <a:p>
+            <a:pPr algn="l"/>
+            <a:r>
+              <a:rPr sz="1200" b="1" i="0">
+                <a:solidFill>
+                  <a:srgbClr val="5ED3A8"/>
+                </a:solidFill>
+                <a:latin typeface="Calibri"/>
+              </a:rPr>
+              <a:t>2 Obligation graph  </a:t>
+            </a:r>
+            <a:r>
+              <a:rPr sz="1100" b="0" i="0">
+                <a:solidFill>
+                  <a:srgbClr val="FFFFFF"/>
+                </a:solidFill>
+                <a:latin typeface="Calibri"/>
+              </a:rPr>
+              <a:t>Built; EMI and stock order as extension edges with lag and probability</a:t>
+            </a:r>
+          </a:p>
+        </p:txBody>
+      </p:sp>
+      <p:sp>
+        <p:nvSpPr>
+          <p:cNvPr id="11" name="TextBox 10"/>
+          <p:cNvSpPr txBox="1"/>
+          <p:nvPr/>
+        </p:nvSpPr>
+        <p:spPr>
+          <a:xfrm>
+            <a:off x="731520" y="2962656"/>
+            <a:ext cx="3246120" cy="411480"/>
+          </a:xfrm>
+          <a:prstGeom prst="rect">
+            <a:avLst/>
+          </a:prstGeom>
+          <a:noFill/>
+        </p:spPr>
+        <p:txBody>
+          <a:bodyPr wrap="square" lIns="0" rIns="0" tIns="0" bIns="0" anchor="t">
+            <a:spAutoFit/>
+          </a:bodyPr>
+          <a:lstStyle/>
+          <a:p>
+            <a:pPr algn="l"/>
+            <a:r>
+              <a:rPr sz="1200" b="1" i="0">
+                <a:solidFill>
+                  <a:srgbClr val="5ED3A8"/>
+                </a:solidFill>
+                <a:latin typeface="Calibri"/>
+              </a:rPr>
+              <a:t>3 Promise ledger  </a:t>
+            </a:r>
+            <a:r>
+              <a:rPr sz="1100" b="0" i="0">
+                <a:solidFill>
+                  <a:srgbClr val="FFFFFF"/>
+                </a:solidFill>
+                <a:latin typeface="Calibri"/>
+              </a:rPr>
+              <a:t>Built; SQLite, repaired and closed on proof</a:t>
+            </a:r>
+          </a:p>
+        </p:txBody>
+      </p:sp>
+      <p:sp>
+        <p:nvSpPr>
+          <p:cNvPr id="12" name="Rounded Rectangle 11"/>
           <p:cNvSpPr/>
           <p:nvPr/>
         </p:nvSpPr>
         <p:spPr>
           <a:xfrm>
-            <a:off x="548640" y="2724912"/>
-            <a:ext cx="6583680" cy="1051560"/>
+            <a:off x="4297679" y="1417320"/>
+            <a:ext cx="3566160" cy="2331720"/>
           </a:xfrm>
           <a:prstGeom prst="roundRect">
             <a:avLst>
@@ -6241,84 +6409,181 @@
       </p:sp>
       <p:sp>
         <p:nvSpPr>
-          <p:cNvPr id="11" name="TextBox 10"/>
-          <p:cNvSpPr txBox="1"/>
-          <p:nvPr/>
-        </p:nvSpPr>
-        <p:spPr>
-          <a:xfrm>
-            <a:off x="777240" y="2834640"/>
-            <a:ext cx="6126480" cy="365760"/>
-          </a:xfrm>
-          <a:prstGeom prst="rect">
-            <a:avLst/>
-          </a:prstGeom>
-          <a:noFill/>
-        </p:spPr>
-        <p:txBody>
-          <a:bodyPr wrap="square" lIns="0" rIns="0" tIns="0" bIns="0" anchor="t">
-            <a:spAutoFit/>
-          </a:bodyPr>
-          <a:lstStyle/>
-          <a:p>
-            <a:pPr algn="l"/>
-            <a:r>
-              <a:rPr sz="1700" b="1" i="0">
+          <p:cNvPr id="13" name="TextBox 12"/>
+          <p:cNvSpPr txBox="1"/>
+          <p:nvPr/>
+        </p:nvSpPr>
+        <p:spPr>
+          <a:xfrm>
+            <a:off x="4480559" y="1527048"/>
+            <a:ext cx="3200400" cy="274320"/>
+          </a:xfrm>
+          <a:prstGeom prst="rect">
+            <a:avLst/>
+          </a:prstGeom>
+          <a:noFill/>
+        </p:spPr>
+        <p:txBody>
+          <a:bodyPr wrap="square" lIns="0" rIns="0" tIns="0" bIns="0" anchor="t">
+            <a:spAutoFit/>
+          </a:bodyPr>
+          <a:lstStyle/>
+          <a:p>
+            <a:pPr algn="l"/>
+            <a:r>
+              <a:rPr sz="1200" b="1" i="0">
                 <a:solidFill>
                   <a:srgbClr val="FFBE3D"/>
                 </a:solidFill>
                 <a:latin typeface="Calibri"/>
               </a:rPr>
-              <a:t>The plain agent is cheaper here</a:t>
-            </a:r>
-          </a:p>
-        </p:txBody>
-      </p:sp>
-      <p:sp>
-        <p:nvSpPr>
-          <p:cNvPr id="12" name="TextBox 11"/>
-          <p:cNvSpPr txBox="1"/>
-          <p:nvPr/>
-        </p:nvSpPr>
-        <p:spPr>
-          <a:xfrm>
-            <a:off x="777240" y="3227832"/>
-            <a:ext cx="6126480" cy="548640"/>
-          </a:xfrm>
-          <a:prstGeom prst="rect">
-            <a:avLst/>
-          </a:prstGeom>
-          <a:noFill/>
-        </p:spPr>
-        <p:txBody>
-          <a:bodyPr wrap="square" lIns="0" rIns="0" tIns="0" bIns="0" anchor="t">
-            <a:spAutoFit/>
-          </a:bodyPr>
-          <a:lstStyle/>
-          <a:p>
-            <a:pPr algn="l"/>
-            <a:r>
-              <a:rPr sz="1400" b="0" i="0">
+              <a:t>PREDICT AND DECIDE</a:t>
+            </a:r>
+          </a:p>
+        </p:txBody>
+      </p:sp>
+      <p:sp>
+        <p:nvSpPr>
+          <p:cNvPr id="14" name="TextBox 13"/>
+          <p:cNvSpPr txBox="1"/>
+          <p:nvPr/>
+        </p:nvSpPr>
+        <p:spPr>
+          <a:xfrm>
+            <a:off x="4480559" y="1828800"/>
+            <a:ext cx="3246120" cy="411480"/>
+          </a:xfrm>
+          <a:prstGeom prst="rect">
+            <a:avLst/>
+          </a:prstGeom>
+          <a:noFill/>
+        </p:spPr>
+        <p:txBody>
+          <a:bodyPr wrap="square" lIns="0" rIns="0" tIns="0" bIns="0" anchor="t">
+            <a:spAutoFit/>
+          </a:bodyPr>
+          <a:lstStyle/>
+          <a:p>
+            <a:pPr algn="l"/>
+            <a:r>
+              <a:rPr sz="1200" b="1" i="0">
+                <a:solidFill>
+                  <a:srgbClr val="5ED3A8"/>
+                </a:solidFill>
+                <a:latin typeface="Calibri"/>
+              </a:rPr>
+              <a:t>4 Simulator  </a:t>
+            </a:r>
+            <a:r>
+              <a:rPr sz="1100" b="0" i="0">
                 <a:solidFill>
                   <a:srgbClr val="FFFFFF"/>
                 </a:solidFill>
                 <a:latin typeface="Calibri"/>
               </a:rPr>
-              <a:t>About ₹49 vs ₹55 per case in the modeled cost, and the answer flips in 16 of 36 assumption combinations.</a:t>
-            </a:r>
-          </a:p>
-        </p:txBody>
-      </p:sp>
-      <p:sp>
-        <p:nvSpPr>
-          <p:cNvPr id="13" name="Rounded Rectangle 12"/>
+              <a:t>Built, seeded, 2,000 samples</a:t>
+            </a:r>
+          </a:p>
+        </p:txBody>
+      </p:sp>
+      <p:sp>
+        <p:nvSpPr>
+          <p:cNvPr id="15" name="TextBox 14"/>
+          <p:cNvSpPr txBox="1"/>
+          <p:nvPr/>
+        </p:nvSpPr>
+        <p:spPr>
+          <a:xfrm>
+            <a:off x="4480559" y="2395728"/>
+            <a:ext cx="3246120" cy="411480"/>
+          </a:xfrm>
+          <a:prstGeom prst="rect">
+            <a:avLst/>
+          </a:prstGeom>
+          <a:noFill/>
+        </p:spPr>
+        <p:txBody>
+          <a:bodyPr wrap="square" lIns="0" rIns="0" tIns="0" bIns="0" anchor="t">
+            <a:spAutoFit/>
+          </a:bodyPr>
+          <a:lstStyle/>
+          <a:p>
+            <a:pPr algn="l"/>
+            <a:r>
+              <a:rPr sz="1200" b="1" i="0">
+                <a:solidFill>
+                  <a:srgbClr val="5ED3A8"/>
+                </a:solidFill>
+                <a:latin typeface="Calibri"/>
+              </a:rPr>
+              <a:t>5 Reverse engine  </a:t>
+            </a:r>
+            <a:r>
+              <a:rPr sz="1100" b="0" i="0">
+                <a:solidFill>
+                  <a:srgbClr val="FFFFFF"/>
+                </a:solidFill>
+                <a:latin typeface="Calibri"/>
+              </a:rPr>
+              <a:t>Built, with do-nothing</a:t>
+            </a:r>
+          </a:p>
+        </p:txBody>
+      </p:sp>
+      <p:sp>
+        <p:nvSpPr>
+          <p:cNvPr id="16" name="TextBox 15"/>
+          <p:cNvSpPr txBox="1"/>
+          <p:nvPr/>
+        </p:nvSpPr>
+        <p:spPr>
+          <a:xfrm>
+            <a:off x="4480559" y="2962656"/>
+            <a:ext cx="3246120" cy="411480"/>
+          </a:xfrm>
+          <a:prstGeom prst="rect">
+            <a:avLst/>
+          </a:prstGeom>
+          <a:noFill/>
+        </p:spPr>
+        <p:txBody>
+          <a:bodyPr wrap="square" lIns="0" rIns="0" tIns="0" bIns="0" anchor="t">
+            <a:spAutoFit/>
+          </a:bodyPr>
+          <a:lstStyle/>
+          <a:p>
+            <a:pPr algn="l"/>
+            <a:r>
+              <a:rPr sz="1200" b="1" i="0">
+                <a:solidFill>
+                  <a:srgbClr val="5ED3A8"/>
+                </a:solidFill>
+                <a:latin typeface="Calibri"/>
+              </a:rPr>
+              <a:t>6 Robustness  </a:t>
+            </a:r>
+            <a:r>
+              <a:rPr sz="1100" b="0" i="0">
+                <a:solidFill>
+                  <a:srgbClr val="FFFFFF"/>
+                </a:solidFill>
+                <a:latin typeface="Calibri"/>
+              </a:rPr>
+              <a:t>Built: decision stability</a:t>
+            </a:r>
+          </a:p>
+        </p:txBody>
+      </p:sp>
+      <p:sp>
+        <p:nvSpPr>
+          <p:cNvPr id="17" name="Rounded Rectangle 16"/>
           <p:cNvSpPr/>
           <p:nvPr/>
         </p:nvSpPr>
         <p:spPr>
           <a:xfrm>
-            <a:off x="548640" y="3895344"/>
-            <a:ext cx="6583680" cy="1051560"/>
+            <a:off x="8046719" y="1417320"/>
+            <a:ext cx="3566160" cy="2331720"/>
           </a:xfrm>
           <a:prstGeom prst="roundRect">
             <a:avLst>
@@ -6359,84 +6624,269 @@
       </p:sp>
       <p:sp>
         <p:nvSpPr>
-          <p:cNvPr id="14" name="TextBox 13"/>
-          <p:cNvSpPr txBox="1"/>
-          <p:nvPr/>
-        </p:nvSpPr>
-        <p:spPr>
-          <a:xfrm>
-            <a:off x="777240" y="4005072"/>
-            <a:ext cx="6126480" cy="365760"/>
-          </a:xfrm>
-          <a:prstGeom prst="rect">
-            <a:avLst/>
-          </a:prstGeom>
-          <a:noFill/>
-        </p:spPr>
-        <p:txBody>
-          <a:bodyPr wrap="square" lIns="0" rIns="0" tIns="0" bIns="0" anchor="t">
-            <a:spAutoFit/>
-          </a:bodyPr>
-          <a:lstStyle/>
-          <a:p>
-            <a:pPr algn="l"/>
-            <a:r>
-              <a:rPr sz="1700" b="1" i="0">
+          <p:cNvPr id="18" name="TextBox 17"/>
+          <p:cNvSpPr txBox="1"/>
+          <p:nvPr/>
+        </p:nvSpPr>
+        <p:spPr>
+          <a:xfrm>
+            <a:off x="8229599" y="1527048"/>
+            <a:ext cx="3200400" cy="274320"/>
+          </a:xfrm>
+          <a:prstGeom prst="rect">
+            <a:avLst/>
+          </a:prstGeom>
+          <a:noFill/>
+        </p:spPr>
+        <p:txBody>
+          <a:bodyPr wrap="square" lIns="0" rIns="0" tIns="0" bIns="0" anchor="t">
+            <a:spAutoFit/>
+          </a:bodyPr>
+          <a:lstStyle/>
+          <a:p>
+            <a:pPr algn="l"/>
+            <a:r>
+              <a:rPr sz="1200" b="1" i="0">
                 <a:solidFill>
                   <a:srgbClr val="FFBE3D"/>
                 </a:solidFill>
                 <a:latin typeface="Calibri"/>
               </a:rPr>
-              <a:t>The benchmark is self-authored</a:t>
-            </a:r>
-          </a:p>
-        </p:txBody>
-      </p:sp>
-      <p:sp>
-        <p:nvSpPr>
-          <p:cNvPr id="15" name="TextBox 14"/>
-          <p:cNvSpPr txBox="1"/>
-          <p:nvPr/>
-        </p:nvSpPr>
-        <p:spPr>
-          <a:xfrm>
-            <a:off x="777240" y="4398264"/>
-            <a:ext cx="6126480" cy="548640"/>
-          </a:xfrm>
-          <a:prstGeom prst="rect">
-            <a:avLst/>
-          </a:prstGeom>
-          <a:noFill/>
-        </p:spPr>
-        <p:txBody>
-          <a:bodyPr wrap="square" lIns="0" rIns="0" tIns="0" bIns="0" anchor="t">
-            <a:spAutoFit/>
-          </a:bodyPr>
-          <a:lstStyle/>
-          <a:p>
-            <a:pPr algn="l"/>
-            <a:r>
-              <a:rPr sz="1400" b="0" i="0">
+              <a:t>ACT WITH HUMANS</a:t>
+            </a:r>
+          </a:p>
+        </p:txBody>
+      </p:sp>
+      <p:sp>
+        <p:nvSpPr>
+          <p:cNvPr id="19" name="TextBox 18"/>
+          <p:cNvSpPr txBox="1"/>
+          <p:nvPr/>
+        </p:nvSpPr>
+        <p:spPr>
+          <a:xfrm>
+            <a:off x="8229599" y="1828800"/>
+            <a:ext cx="3246120" cy="411480"/>
+          </a:xfrm>
+          <a:prstGeom prst="rect">
+            <a:avLst/>
+          </a:prstGeom>
+          <a:noFill/>
+        </p:spPr>
+        <p:txBody>
+          <a:bodyPr wrap="square" lIns="0" rIns="0" tIns="0" bIns="0" anchor="t">
+            <a:spAutoFit/>
+          </a:bodyPr>
+          <a:lstStyle/>
+          <a:p>
+            <a:pPr algn="l"/>
+            <a:r>
+              <a:rPr sz="1200" b="1" i="0">
+                <a:solidFill>
+                  <a:srgbClr val="5ED3A8"/>
+                </a:solidFill>
+                <a:latin typeface="Calibri"/>
+              </a:rPr>
+              <a:t>7 Action layer  </a:t>
+            </a:r>
+            <a:r>
+              <a:rPr sz="1100" b="0" i="0">
                 <a:solidFill>
                   <a:srgbClr val="FFFFFF"/>
                 </a:solidFill>
                 <a:latin typeface="Calibri"/>
               </a:rPr>
-              <a:t>We wrote scenarios, ground truth and scorer. Independent scenarios are next.</a:t>
-            </a:r>
-          </a:p>
-        </p:txBody>
-      </p:sp>
-      <p:sp>
-        <p:nvSpPr>
-          <p:cNvPr id="16" name="Rounded Rectangle 15"/>
+              <a:t>Built: six actions, dry run</a:t>
+            </a:r>
+          </a:p>
+        </p:txBody>
+      </p:sp>
+      <p:sp>
+        <p:nvSpPr>
+          <p:cNvPr id="20" name="TextBox 19"/>
+          <p:cNvSpPr txBox="1"/>
+          <p:nvPr/>
+        </p:nvSpPr>
+        <p:spPr>
+          <a:xfrm>
+            <a:off x="8229599" y="2258568"/>
+            <a:ext cx="3246120" cy="411480"/>
+          </a:xfrm>
+          <a:prstGeom prst="rect">
+            <a:avLst/>
+          </a:prstGeom>
+          <a:noFill/>
+        </p:spPr>
+        <p:txBody>
+          <a:bodyPr wrap="square" lIns="0" rIns="0" tIns="0" bIns="0" anchor="t">
+            <a:spAutoFit/>
+          </a:bodyPr>
+          <a:lstStyle/>
+          <a:p>
+            <a:pPr algn="l"/>
+            <a:r>
+              <a:rPr sz="1200" b="1" i="0">
+                <a:solidFill>
+                  <a:srgbClr val="5ED3A8"/>
+                </a:solidFill>
+                <a:latin typeface="Calibri"/>
+              </a:rPr>
+              <a:t>8 Trust ladder  </a:t>
+            </a:r>
+            <a:r>
+              <a:rPr sz="1100" b="0" i="0">
+                <a:solidFill>
+                  <a:srgbClr val="FFFFFF"/>
+                </a:solidFill>
+                <a:latin typeface="Calibri"/>
+              </a:rPr>
+              <a:t>Built; widens only on evidence</a:t>
+            </a:r>
+          </a:p>
+        </p:txBody>
+      </p:sp>
+      <p:sp>
+        <p:nvSpPr>
+          <p:cNvPr id="21" name="TextBox 20"/>
+          <p:cNvSpPr txBox="1"/>
+          <p:nvPr/>
+        </p:nvSpPr>
+        <p:spPr>
+          <a:xfrm>
+            <a:off x="8229599" y="2688335"/>
+            <a:ext cx="3246120" cy="411480"/>
+          </a:xfrm>
+          <a:prstGeom prst="rect">
+            <a:avLst/>
+          </a:prstGeom>
+          <a:noFill/>
+        </p:spPr>
+        <p:txBody>
+          <a:bodyPr wrap="square" lIns="0" rIns="0" tIns="0" bIns="0" anchor="t">
+            <a:spAutoFit/>
+          </a:bodyPr>
+          <a:lstStyle/>
+          <a:p>
+            <a:pPr algn="l"/>
+            <a:r>
+              <a:rPr sz="1200" b="1" i="0">
+                <a:solidFill>
+                  <a:srgbClr val="5ED3A8"/>
+                </a:solidFill>
+                <a:latin typeface="Calibri"/>
+              </a:rPr>
+              <a:t>9 Memos, learned rules  </a:t>
+            </a:r>
+            <a:r>
+              <a:rPr sz="1100" b="0" i="0">
+                <a:solidFill>
+                  <a:srgbClr val="FFFFFF"/>
+                </a:solidFill>
+                <a:latin typeface="Calibri"/>
+              </a:rPr>
+              <a:t>Built; analyst confirms each rule</a:t>
+            </a:r>
+          </a:p>
+        </p:txBody>
+      </p:sp>
+      <p:sp>
+        <p:nvSpPr>
+          <p:cNvPr id="22" name="TextBox 21"/>
+          <p:cNvSpPr txBox="1"/>
+          <p:nvPr/>
+        </p:nvSpPr>
+        <p:spPr>
+          <a:xfrm>
+            <a:off x="8229599" y="3118103"/>
+            <a:ext cx="3246120" cy="411480"/>
+          </a:xfrm>
+          <a:prstGeom prst="rect">
+            <a:avLst/>
+          </a:prstGeom>
+          <a:noFill/>
+        </p:spPr>
+        <p:txBody>
+          <a:bodyPr wrap="square" lIns="0" rIns="0" tIns="0" bIns="0" anchor="t">
+            <a:spAutoFit/>
+          </a:bodyPr>
+          <a:lstStyle/>
+          <a:p>
+            <a:pPr algn="l"/>
+            <a:r>
+              <a:rPr sz="1200" b="1" i="0">
+                <a:solidFill>
+                  <a:srgbClr val="41D7E0"/>
+                </a:solidFill>
+                <a:latin typeface="Calibri"/>
+              </a:rPr>
+              <a:t>10 Voice  </a:t>
+            </a:r>
+            <a:r>
+              <a:rPr sz="1100" b="0" i="0">
+                <a:solidFill>
+                  <a:srgbClr val="FFFFFF"/>
+                </a:solidFill>
+                <a:latin typeface="Calibri"/>
+              </a:rPr>
+              <a:t>Simulated: browser voice, Soundbox policy</a:t>
+            </a:r>
+          </a:p>
+        </p:txBody>
+      </p:sp>
+      <p:sp>
+        <p:nvSpPr>
+          <p:cNvPr id="23" name="TextBox 22"/>
+          <p:cNvSpPr txBox="1"/>
+          <p:nvPr/>
+        </p:nvSpPr>
+        <p:spPr>
+          <a:xfrm>
+            <a:off x="8229599" y="3547871"/>
+            <a:ext cx="3246120" cy="411480"/>
+          </a:xfrm>
+          <a:prstGeom prst="rect">
+            <a:avLst/>
+          </a:prstGeom>
+          <a:noFill/>
+        </p:spPr>
+        <p:txBody>
+          <a:bodyPr wrap="square" lIns="0" rIns="0" tIns="0" bIns="0" anchor="t">
+            <a:spAutoFit/>
+          </a:bodyPr>
+          <a:lstStyle/>
+          <a:p>
+            <a:pPr algn="l"/>
+            <a:r>
+              <a:rPr sz="1200" b="1" i="0">
+                <a:solidFill>
+                  <a:srgbClr val="5ED3A8"/>
+                </a:solidFill>
+                <a:latin typeface="Calibri"/>
+              </a:rPr>
+              <a:t>11 Promise repair  </a:t>
+            </a:r>
+            <a:r>
+              <a:rPr sz="1100" b="0" i="0">
+                <a:solidFill>
+                  <a:srgbClr val="FFFFFF"/>
+                </a:solidFill>
+                <a:latin typeface="Calibri"/>
+              </a:rPr>
+              <a:t>Built: date only if supported</a:t>
+            </a:r>
+          </a:p>
+        </p:txBody>
+      </p:sp>
+      <p:sp>
+        <p:nvSpPr>
+          <p:cNvPr id="24" name="Rounded Rectangle 23"/>
           <p:cNvSpPr/>
           <p:nvPr/>
         </p:nvSpPr>
         <p:spPr>
           <a:xfrm>
-            <a:off x="548640" y="5065776"/>
-            <a:ext cx="6583680" cy="1051560"/>
+            <a:off x="548640" y="3931920"/>
+            <a:ext cx="3566160" cy="2331720"/>
           </a:xfrm>
           <a:prstGeom prst="roundRect">
             <a:avLst>
@@ -6477,84 +6927,181 @@
       </p:sp>
       <p:sp>
         <p:nvSpPr>
-          <p:cNvPr id="17" name="TextBox 16"/>
-          <p:cNvSpPr txBox="1"/>
-          <p:nvPr/>
-        </p:nvSpPr>
-        <p:spPr>
-          <a:xfrm>
-            <a:off x="777240" y="5175504"/>
-            <a:ext cx="6126480" cy="365760"/>
-          </a:xfrm>
-          <a:prstGeom prst="rect">
-            <a:avLst/>
-          </a:prstGeom>
-          <a:noFill/>
-        </p:spPr>
-        <p:txBody>
-          <a:bodyPr wrap="square" lIns="0" rIns="0" tIns="0" bIns="0" anchor="t">
-            <a:spAutoFit/>
-          </a:bodyPr>
-          <a:lstStyle/>
-          <a:p>
-            <a:pPr algn="l"/>
-            <a:r>
-              <a:rPr sz="1700" b="1" i="0">
+          <p:cNvPr id="25" name="TextBox 24"/>
+          <p:cNvSpPr txBox="1"/>
+          <p:nvPr/>
+        </p:nvSpPr>
+        <p:spPr>
+          <a:xfrm>
+            <a:off x="731520" y="4041648"/>
+            <a:ext cx="3200400" cy="274320"/>
+          </a:xfrm>
+          <a:prstGeom prst="rect">
+            <a:avLst/>
+          </a:prstGeom>
+          <a:noFill/>
+        </p:spPr>
+        <p:txBody>
+          <a:bodyPr wrap="square" lIns="0" rIns="0" tIns="0" bIns="0" anchor="t">
+            <a:spAutoFit/>
+          </a:bodyPr>
+          <a:lstStyle/>
+          <a:p>
+            <a:pPr algn="l"/>
+            <a:r>
+              <a:rPr sz="1200" b="1" i="0">
                 <a:solidFill>
                   <a:srgbClr val="FFBE3D"/>
                 </a:solidFill>
                 <a:latin typeface="Calibri"/>
               </a:rPr>
-              <a:t>Understanding is imperfect</a:t>
-            </a:r>
-          </a:p>
-        </p:txBody>
-      </p:sp>
-      <p:sp>
-        <p:nvSpPr>
-          <p:cNvPr id="18" name="TextBox 17"/>
-          <p:cNvSpPr txBox="1"/>
-          <p:nvPr/>
-        </p:nvSpPr>
-        <p:spPr>
-          <a:xfrm>
-            <a:off x="777240" y="5568696"/>
-            <a:ext cx="6126480" cy="548640"/>
-          </a:xfrm>
-          <a:prstGeom prst="rect">
-            <a:avLst/>
-          </a:prstGeom>
-          <a:noFill/>
-        </p:spPr>
-        <p:txBody>
-          <a:bodyPr wrap="square" lIns="0" rIns="0" tIns="0" bIns="0" anchor="t">
-            <a:spAutoFit/>
-          </a:bodyPr>
-          <a:lstStyle/>
-          <a:p>
-            <a:pPr algn="l"/>
-            <a:r>
-              <a:rPr sz="1400" b="0" i="0">
+              <a:t>VERIFY AND OFFER</a:t>
+            </a:r>
+          </a:p>
+        </p:txBody>
+      </p:sp>
+      <p:sp>
+        <p:nvSpPr>
+          <p:cNvPr id="26" name="TextBox 25"/>
+          <p:cNvSpPr txBox="1"/>
+          <p:nvPr/>
+        </p:nvSpPr>
+        <p:spPr>
+          <a:xfrm>
+            <a:off x="731520" y="4343400"/>
+            <a:ext cx="3246120" cy="411480"/>
+          </a:xfrm>
+          <a:prstGeom prst="rect">
+            <a:avLst/>
+          </a:prstGeom>
+          <a:noFill/>
+        </p:spPr>
+        <p:txBody>
+          <a:bodyPr wrap="square" lIns="0" rIns="0" tIns="0" bIns="0" anchor="t">
+            <a:spAutoFit/>
+          </a:bodyPr>
+          <a:lstStyle/>
+          <a:p>
+            <a:pPr algn="l"/>
+            <a:r>
+              <a:rPr sz="1200" b="1" i="0">
+                <a:solidFill>
+                  <a:srgbClr val="FFBE3D"/>
+                </a:solidFill>
+                <a:latin typeface="Calibri"/>
+              </a:rPr>
+              <a:t>12 Verification loop  </a:t>
+            </a:r>
+            <a:r>
+              <a:rPr sz="1100" b="0" i="0">
                 <a:solidFill>
                   <a:srgbClr val="FFFFFF"/>
                 </a:solidFill>
                 <a:latin typeface="Calibri"/>
               </a:rPr>
-              <a:t>Intent right 80% on 120 labelled messages; 5 of 14 forbidden asks missed, none unsafe.</a:t>
-            </a:r>
-          </a:p>
-        </p:txBody>
-      </p:sp>
-      <p:sp>
-        <p:nvSpPr>
-          <p:cNvPr id="19" name="Rounded Rectangle 18"/>
+              <a:t>Partial: re-simulates and records effect; not fed back into the engine</a:t>
+            </a:r>
+          </a:p>
+        </p:txBody>
+      </p:sp>
+      <p:sp>
+        <p:nvSpPr>
+          <p:cNvPr id="27" name="TextBox 26"/>
+          <p:cNvSpPr txBox="1"/>
+          <p:nvPr/>
+        </p:nvSpPr>
+        <p:spPr>
+          <a:xfrm>
+            <a:off x="731520" y="4910328"/>
+            <a:ext cx="3246120" cy="411480"/>
+          </a:xfrm>
+          <a:prstGeom prst="rect">
+            <a:avLst/>
+          </a:prstGeom>
+          <a:noFill/>
+        </p:spPr>
+        <p:txBody>
+          <a:bodyPr wrap="square" lIns="0" rIns="0" tIns="0" bIns="0" anchor="t">
+            <a:spAutoFit/>
+          </a:bodyPr>
+          <a:lstStyle/>
+          <a:p>
+            <a:pPr algn="l"/>
+            <a:r>
+              <a:rPr sz="1200" b="1" i="0">
+                <a:solidFill>
+                  <a:srgbClr val="41D7E0"/>
+                </a:solidFill>
+                <a:latin typeface="Calibri"/>
+              </a:rPr>
+              <a:t>13 Bridge offers  </a:t>
+            </a:r>
+            <a:r>
+              <a:rPr sz="1100" b="0" i="0">
+                <a:solidFill>
+                  <a:srgbClr val="FFFFFF"/>
+                </a:solidFill>
+                <a:latin typeface="Calibri"/>
+              </a:rPr>
+              <a:t>Built, simulated lender; explicit tap only</a:t>
+            </a:r>
+          </a:p>
+        </p:txBody>
+      </p:sp>
+      <p:sp>
+        <p:nvSpPr>
+          <p:cNvPr id="28" name="TextBox 27"/>
+          <p:cNvSpPr txBox="1"/>
+          <p:nvPr/>
+        </p:nvSpPr>
+        <p:spPr>
+          <a:xfrm>
+            <a:off x="731520" y="5477256"/>
+            <a:ext cx="3246120" cy="411480"/>
+          </a:xfrm>
+          <a:prstGeom prst="rect">
+            <a:avLst/>
+          </a:prstGeom>
+          <a:noFill/>
+        </p:spPr>
+        <p:txBody>
+          <a:bodyPr wrap="square" lIns="0" rIns="0" tIns="0" bIns="0" anchor="t">
+            <a:spAutoFit/>
+          </a:bodyPr>
+          <a:lstStyle/>
+          <a:p>
+            <a:pPr algn="l"/>
+            <a:r>
+              <a:rPr sz="1200" b="1" i="0">
+                <a:solidFill>
+                  <a:srgbClr val="41D7E0"/>
+                </a:solidFill>
+                <a:latin typeface="Calibri"/>
+              </a:rPr>
+              <a:t>14 Portfolio view  </a:t>
+            </a:r>
+            <a:r>
+              <a:rPr sz="1100" b="0" i="0">
+                <a:solidFill>
+                  <a:srgbClr val="FFFFFF"/>
+                </a:solidFill>
+                <a:latin typeface="Calibri"/>
+              </a:rPr>
+              <a:t>Built, 200 synthetic merchants</a:t>
+            </a:r>
+          </a:p>
+        </p:txBody>
+      </p:sp>
+      <p:sp>
+        <p:nvSpPr>
+          <p:cNvPr id="29" name="Rounded Rectangle 28"/>
           <p:cNvSpPr/>
           <p:nvPr/>
         </p:nvSpPr>
         <p:spPr>
           <a:xfrm>
-            <a:off x="7406640" y="1554480"/>
-            <a:ext cx="4206240" cy="4572000"/>
+            <a:off x="4297679" y="3931920"/>
+            <a:ext cx="3566160" cy="2331720"/>
           </a:xfrm>
           <a:prstGeom prst="roundRect">
             <a:avLst>
@@ -6595,6 +7142,1046 @@
       </p:sp>
       <p:sp>
         <p:nvSpPr>
+          <p:cNvPr id="30" name="TextBox 29"/>
+          <p:cNvSpPr txBox="1"/>
+          <p:nvPr/>
+        </p:nvSpPr>
+        <p:spPr>
+          <a:xfrm>
+            <a:off x="4480559" y="4041648"/>
+            <a:ext cx="3200400" cy="274320"/>
+          </a:xfrm>
+          <a:prstGeom prst="rect">
+            <a:avLst/>
+          </a:prstGeom>
+          <a:noFill/>
+        </p:spPr>
+        <p:txBody>
+          <a:bodyPr wrap="square" lIns="0" rIns="0" tIns="0" bIns="0" anchor="t">
+            <a:spAutoFit/>
+          </a:bodyPr>
+          <a:lstStyle/>
+          <a:p>
+            <a:pPr algn="l"/>
+            <a:r>
+              <a:rPr sz="1200" b="1" i="0">
+                <a:solidFill>
+                  <a:srgbClr val="FFBE3D"/>
+                </a:solidFill>
+                <a:latin typeface="Calibri"/>
+              </a:rPr>
+              <a:t>SAFETY</a:t>
+            </a:r>
+          </a:p>
+        </p:txBody>
+      </p:sp>
+      <p:sp>
+        <p:nvSpPr>
+          <p:cNvPr id="31" name="TextBox 30"/>
+          <p:cNvSpPr txBox="1"/>
+          <p:nvPr/>
+        </p:nvSpPr>
+        <p:spPr>
+          <a:xfrm>
+            <a:off x="4480559" y="4343400"/>
+            <a:ext cx="3246120" cy="411480"/>
+          </a:xfrm>
+          <a:prstGeom prst="rect">
+            <a:avLst/>
+          </a:prstGeom>
+          <a:noFill/>
+        </p:spPr>
+        <p:txBody>
+          <a:bodyPr wrap="square" lIns="0" rIns="0" tIns="0" bIns="0" anchor="t">
+            <a:spAutoFit/>
+          </a:bodyPr>
+          <a:lstStyle/>
+          <a:p>
+            <a:pPr algn="l"/>
+            <a:r>
+              <a:rPr sz="1200" b="1" i="0">
+                <a:solidFill>
+                  <a:srgbClr val="5ED3A8"/>
+                </a:solidFill>
+                <a:latin typeface="Calibri"/>
+              </a:rPr>
+              <a:t>15 Firewall  </a:t>
+            </a:r>
+            <a:r>
+              <a:rPr sz="1100" b="0" i="0">
+                <a:solidFill>
+                  <a:srgbClr val="FFFFFF"/>
+                </a:solidFill>
+                <a:latin typeface="Calibri"/>
+              </a:rPr>
+              <a:t>Built, 44 attacks, 0 unsafe</a:t>
+            </a:r>
+          </a:p>
+        </p:txBody>
+      </p:sp>
+      <p:sp>
+        <p:nvSpPr>
+          <p:cNvPr id="32" name="TextBox 31"/>
+          <p:cNvSpPr txBox="1"/>
+          <p:nvPr/>
+        </p:nvSpPr>
+        <p:spPr>
+          <a:xfrm>
+            <a:off x="4480559" y="4910328"/>
+            <a:ext cx="3246120" cy="411480"/>
+          </a:xfrm>
+          <a:prstGeom prst="rect">
+            <a:avLst/>
+          </a:prstGeom>
+          <a:noFill/>
+        </p:spPr>
+        <p:txBody>
+          <a:bodyPr wrap="square" lIns="0" rIns="0" tIns="0" bIns="0" anchor="t">
+            <a:spAutoFit/>
+          </a:bodyPr>
+          <a:lstStyle/>
+          <a:p>
+            <a:pPr algn="l"/>
+            <a:r>
+              <a:rPr sz="1200" b="1" i="0">
+                <a:solidFill>
+                  <a:srgbClr val="5ED3A8"/>
+                </a:solidFill>
+                <a:latin typeface="Calibri"/>
+              </a:rPr>
+              <a:t>16 Audit trail  </a:t>
+            </a:r>
+            <a:r>
+              <a:rPr sz="1100" b="0" i="0">
+                <a:solidFill>
+                  <a:srgbClr val="FFFFFF"/>
+                </a:solidFill>
+                <a:latin typeface="Calibri"/>
+              </a:rPr>
+              <a:t>Built; merchant “why”; no case-file export</a:t>
+            </a:r>
+          </a:p>
+        </p:txBody>
+      </p:sp>
+      <p:sp>
+        <p:nvSpPr>
+          <p:cNvPr id="33" name="Rounded Rectangle 32"/>
+          <p:cNvSpPr/>
+          <p:nvPr/>
+        </p:nvSpPr>
+        <p:spPr>
+          <a:xfrm>
+            <a:off x="8046719" y="3931920"/>
+            <a:ext cx="3566160" cy="2331720"/>
+          </a:xfrm>
+          <a:prstGeom prst="roundRect">
+            <a:avLst>
+              <a:gd name="adj" fmla="val 6000"/>
+            </a:avLst>
+          </a:prstGeom>
+          <a:solidFill>
+            <a:srgbClr val="0848AC"/>
+          </a:solidFill>
+          <a:ln w="12700">
+            <a:solidFill>
+              <a:srgbClr val="407BC7"/>
+            </a:solidFill>
+          </a:ln>
+          <a:effectLst/>
+        </p:spPr>
+        <p:style>
+          <a:lnRef idx="1">
+            <a:schemeClr val="accent1"/>
+          </a:lnRef>
+          <a:fillRef idx="3">
+            <a:schemeClr val="accent1"/>
+          </a:fillRef>
+          <a:effectRef idx="2">
+            <a:schemeClr val="accent1"/>
+          </a:effectRef>
+          <a:fontRef idx="minor">
+            <a:schemeClr val="lt1"/>
+          </a:fontRef>
+        </p:style>
+        <p:txBody>
+          <a:bodyPr rtlCol="0" anchor="ctr"/>
+          <a:lstStyle/>
+          <a:p>
+            <a:pPr algn="ctr"/>
+          </a:p>
+        </p:txBody>
+      </p:sp>
+      <p:sp>
+        <p:nvSpPr>
+          <p:cNvPr id="34" name="TextBox 33"/>
+          <p:cNvSpPr txBox="1"/>
+          <p:nvPr/>
+        </p:nvSpPr>
+        <p:spPr>
+          <a:xfrm>
+            <a:off x="8229599" y="4041648"/>
+            <a:ext cx="3200400" cy="274320"/>
+          </a:xfrm>
+          <a:prstGeom prst="rect">
+            <a:avLst/>
+          </a:prstGeom>
+          <a:noFill/>
+        </p:spPr>
+        <p:txBody>
+          <a:bodyPr wrap="square" lIns="0" rIns="0" tIns="0" bIns="0" anchor="t">
+            <a:spAutoFit/>
+          </a:bodyPr>
+          <a:lstStyle/>
+          <a:p>
+            <a:pPr algn="l"/>
+            <a:r>
+              <a:rPr sz="1200" b="1" i="0">
+                <a:solidFill>
+                  <a:srgbClr val="FFBE3D"/>
+                </a:solidFill>
+                <a:latin typeface="Calibri"/>
+              </a:rPr>
+              <a:t>PROOF</a:t>
+            </a:r>
+          </a:p>
+        </p:txBody>
+      </p:sp>
+      <p:sp>
+        <p:nvSpPr>
+          <p:cNvPr id="35" name="TextBox 34"/>
+          <p:cNvSpPr txBox="1"/>
+          <p:nvPr/>
+        </p:nvSpPr>
+        <p:spPr>
+          <a:xfrm>
+            <a:off x="8229599" y="4343400"/>
+            <a:ext cx="3246120" cy="411480"/>
+          </a:xfrm>
+          <a:prstGeom prst="rect">
+            <a:avLst/>
+          </a:prstGeom>
+          <a:noFill/>
+        </p:spPr>
+        <p:txBody>
+          <a:bodyPr wrap="square" lIns="0" rIns="0" tIns="0" bIns="0" anchor="t">
+            <a:spAutoFit/>
+          </a:bodyPr>
+          <a:lstStyle/>
+          <a:p>
+            <a:pPr algn="l"/>
+            <a:r>
+              <a:rPr sz="1200" b="1" i="0">
+                <a:solidFill>
+                  <a:srgbClr val="5ED3A8"/>
+                </a:solidFill>
+                <a:latin typeface="Calibri"/>
+              </a:rPr>
+              <a:t>17 Benchmark  </a:t>
+            </a:r>
+            <a:r>
+              <a:rPr sz="1100" b="0" i="0">
+                <a:solidFill>
+                  <a:srgbClr val="FFFFFF"/>
+                </a:solidFill>
+                <a:latin typeface="Calibri"/>
+              </a:rPr>
+              <a:t>Built; hand-written set, targets declared first</a:t>
+            </a:r>
+          </a:p>
+        </p:txBody>
+      </p:sp>
+      <p:sp>
+        <p:nvSpPr>
+          <p:cNvPr id="36" name="TextBox 35"/>
+          <p:cNvSpPr txBox="1"/>
+          <p:nvPr/>
+        </p:nvSpPr>
+        <p:spPr>
+          <a:xfrm>
+            <a:off x="8229599" y="4910328"/>
+            <a:ext cx="3246120" cy="411480"/>
+          </a:xfrm>
+          <a:prstGeom prst="rect">
+            <a:avLst/>
+          </a:prstGeom>
+          <a:noFill/>
+        </p:spPr>
+        <p:txBody>
+          <a:bodyPr wrap="square" lIns="0" rIns="0" tIns="0" bIns="0" anchor="t">
+            <a:spAutoFit/>
+          </a:bodyPr>
+          <a:lstStyle/>
+          <a:p>
+            <a:pPr algn="l"/>
+            <a:r>
+              <a:rPr sz="1200" b="1" i="0">
+                <a:solidFill>
+                  <a:srgbClr val="5ED3A8"/>
+                </a:solidFill>
+                <a:latin typeface="Calibri"/>
+              </a:rPr>
+              <a:t>18 Command center  </a:t>
+            </a:r>
+            <a:r>
+              <a:rPr sz="1100" b="0" i="0">
+                <a:solidFill>
+                  <a:srgbClr val="FFFFFF"/>
+                </a:solidFill>
+                <a:latin typeface="Calibri"/>
+              </a:rPr>
+              <a:t>Built</a:t>
+            </a:r>
+          </a:p>
+        </p:txBody>
+      </p:sp>
+      <p:sp>
+        <p:nvSpPr>
+          <p:cNvPr id="37" name="TextBox 36"/>
+          <p:cNvSpPr txBox="1"/>
+          <p:nvPr/>
+        </p:nvSpPr>
+        <p:spPr>
+          <a:xfrm>
+            <a:off x="8229599" y="5477256"/>
+            <a:ext cx="3246120" cy="411480"/>
+          </a:xfrm>
+          <a:prstGeom prst="rect">
+            <a:avLst/>
+          </a:prstGeom>
+          <a:noFill/>
+        </p:spPr>
+        <p:txBody>
+          <a:bodyPr wrap="square" lIns="0" rIns="0" tIns="0" bIns="0" anchor="t">
+            <a:spAutoFit/>
+          </a:bodyPr>
+          <a:lstStyle/>
+          <a:p>
+            <a:pPr algn="l"/>
+            <a:r>
+              <a:rPr sz="1200" b="1" i="0">
+                <a:solidFill>
+                  <a:srgbClr val="41D7E0"/>
+                </a:solidFill>
+                <a:latin typeface="Calibri"/>
+              </a:rPr>
+              <a:t>19 Udhaar recovery  </a:t>
+            </a:r>
+            <a:r>
+              <a:rPr sz="1100" b="0" i="0">
+                <a:solidFill>
+                  <a:srgbClr val="FFFFFF"/>
+                </a:solidFill>
+                <a:latin typeface="Calibri"/>
+              </a:rPr>
+              <a:t>Built, simulated; human decides on hardship</a:t>
+            </a:r>
+          </a:p>
+        </p:txBody>
+      </p:sp>
+    </p:spTree>
+  </p:cSld>
+  <p:clrMapOvr>
+    <a:masterClrMapping/>
+  </p:clrMapOvr>
+</p:sld>
+</file>
+
+<file path=ppt/slides/slide12.xml><?xml version="1.0" encoding="utf-8"?>
+<p:sld xmlns:a="http://schemas.openxmlformats.org/drawingml/2006/main" xmlns:p="http://schemas.openxmlformats.org/presentationml/2006/main" xmlns:r="http://schemas.openxmlformats.org/officeDocument/2006/relationships">
+  <p:cSld>
+    <p:spTree>
+      <p:nvGrpSpPr>
+        <p:cNvPr id="1" name=""/>
+        <p:cNvGrpSpPr/>
+        <p:nvPr/>
+      </p:nvGrpSpPr>
+      <p:grpSpPr/>
+      <p:pic>
+        <p:nvPicPr>
+          <p:cNvPr id="2" name="Picture 1" descr="bg_grid.png"/>
+          <p:cNvPicPr>
+            <a:picLocks noChangeAspect="1"/>
+          </p:cNvPicPr>
+          <p:nvPr/>
+        </p:nvPicPr>
+        <p:blipFill>
+          <a:blip r:embed="rId2"/>
+          <a:stretch>
+            <a:fillRect/>
+          </a:stretch>
+        </p:blipFill>
+        <p:spPr>
+          <a:xfrm>
+            <a:off x="0" y="0"/>
+            <a:ext cx="12191695" cy="6858000"/>
+          </a:xfrm>
+          <a:prstGeom prst="rect">
+            <a:avLst/>
+          </a:prstGeom>
+        </p:spPr>
+      </p:pic>
+      <p:sp>
+        <p:nvSpPr>
+          <p:cNvPr id="3" name="TextBox 2"/>
+          <p:cNvSpPr txBox="1"/>
+          <p:nvPr/>
+        </p:nvSpPr>
+        <p:spPr>
+          <a:xfrm>
+            <a:off x="548640" y="256032"/>
+            <a:ext cx="7315200" cy="274320"/>
+          </a:xfrm>
+          <a:prstGeom prst="rect">
+            <a:avLst/>
+          </a:prstGeom>
+          <a:noFill/>
+        </p:spPr>
+        <p:txBody>
+          <a:bodyPr wrap="square" lIns="0" rIns="0" tIns="0" bIns="0" anchor="t">
+            <a:spAutoFit/>
+          </a:bodyPr>
+          <a:lstStyle/>
+          <a:p>
+            <a:pPr algn="l"/>
+            <a:r>
+              <a:rPr sz="1200" b="1" i="0">
+                <a:solidFill>
+                  <a:srgbClr val="FFBE3D"/>
+                </a:solidFill>
+                <a:latin typeface="Calibri"/>
+              </a:rPr>
+              <a:t>PAYTM × RIPPLE  /  HONEST LIMITS AND NEXT</a:t>
+            </a:r>
+          </a:p>
+        </p:txBody>
+      </p:sp>
+      <p:sp>
+        <p:nvSpPr>
+          <p:cNvPr id="4" name="TextBox 3"/>
+          <p:cNvSpPr txBox="1"/>
+          <p:nvPr/>
+        </p:nvSpPr>
+        <p:spPr>
+          <a:xfrm>
+            <a:off x="10241280" y="256032"/>
+            <a:ext cx="1417320" cy="274320"/>
+          </a:xfrm>
+          <a:prstGeom prst="rect">
+            <a:avLst/>
+          </a:prstGeom>
+          <a:noFill/>
+        </p:spPr>
+        <p:txBody>
+          <a:bodyPr wrap="square" lIns="0" rIns="0" tIns="0" bIns="0" anchor="t">
+            <a:spAutoFit/>
+          </a:bodyPr>
+          <a:lstStyle/>
+          <a:p>
+            <a:pPr algn="r"/>
+            <a:r>
+              <a:rPr sz="1200" b="1" i="0">
+                <a:solidFill>
+                  <a:srgbClr val="B9D3F4"/>
+                </a:solidFill>
+                <a:latin typeface="Calibri"/>
+              </a:rPr>
+              <a:t>12 / 12</a:t>
+            </a:r>
+          </a:p>
+        </p:txBody>
+      </p:sp>
+      <p:sp>
+        <p:nvSpPr>
+          <p:cNvPr id="5" name="TextBox 4"/>
+          <p:cNvSpPr txBox="1"/>
+          <p:nvPr/>
+        </p:nvSpPr>
+        <p:spPr>
+          <a:xfrm>
+            <a:off x="548640" y="6455664"/>
+            <a:ext cx="8229600" cy="256032"/>
+          </a:xfrm>
+          <a:prstGeom prst="rect">
+            <a:avLst/>
+          </a:prstGeom>
+          <a:noFill/>
+        </p:spPr>
+        <p:txBody>
+          <a:bodyPr wrap="square" lIns="0" rIns="0" tIns="0" bIns="0" anchor="t">
+            <a:spAutoFit/>
+          </a:bodyPr>
+          <a:lstStyle/>
+          <a:p>
+            <a:pPr algn="l"/>
+            <a:r>
+              <a:rPr sz="1000" b="0" i="0">
+                <a:solidFill>
+                  <a:srgbClr val="B9D3F4"/>
+                </a:solidFill>
+                <a:latin typeface="Calibri"/>
+              </a:rPr>
+              <a:t>PAYTM MERCHANT AI CHALLENGE  ·  SYNTHETIC DATA ONLY  ·  PROTOTYPE</a:t>
+            </a:r>
+          </a:p>
+        </p:txBody>
+      </p:sp>
+      <p:sp>
+        <p:nvSpPr>
+          <p:cNvPr id="6" name="TextBox 5"/>
+          <p:cNvSpPr txBox="1"/>
+          <p:nvPr/>
+        </p:nvSpPr>
+        <p:spPr>
+          <a:xfrm>
+            <a:off x="548640" y="713232"/>
+            <a:ext cx="11064240" cy="914400"/>
+          </a:xfrm>
+          <a:prstGeom prst="rect">
+            <a:avLst/>
+          </a:prstGeom>
+          <a:noFill/>
+        </p:spPr>
+        <p:txBody>
+          <a:bodyPr wrap="square" lIns="0" rIns="0" tIns="0" bIns="0" anchor="t">
+            <a:spAutoFit/>
+          </a:bodyPr>
+          <a:lstStyle/>
+          <a:p>
+            <a:pPr algn="l"/>
+            <a:r>
+              <a:rPr sz="3200" b="1" i="0">
+                <a:solidFill>
+                  <a:srgbClr val="FFFFFF"/>
+                </a:solidFill>
+                <a:latin typeface="Calibri"/>
+              </a:rPr>
+              <a:t>We show the losses. Then the next steps.</a:t>
+            </a:r>
+          </a:p>
+        </p:txBody>
+      </p:sp>
+      <p:sp>
+        <p:nvSpPr>
+          <p:cNvPr id="7" name="Rounded Rectangle 6"/>
+          <p:cNvSpPr/>
+          <p:nvPr/>
+        </p:nvSpPr>
+        <p:spPr>
+          <a:xfrm>
+            <a:off x="548640" y="1554480"/>
+            <a:ext cx="6583680" cy="1051560"/>
+          </a:xfrm>
+          <a:prstGeom prst="roundRect">
+            <a:avLst>
+              <a:gd name="adj" fmla="val 6000"/>
+            </a:avLst>
+          </a:prstGeom>
+          <a:solidFill>
+            <a:srgbClr val="0848AC"/>
+          </a:solidFill>
+          <a:ln w="12700">
+            <a:solidFill>
+              <a:srgbClr val="407BC7"/>
+            </a:solidFill>
+          </a:ln>
+          <a:effectLst/>
+        </p:spPr>
+        <p:style>
+          <a:lnRef idx="1">
+            <a:schemeClr val="accent1"/>
+          </a:lnRef>
+          <a:fillRef idx="3">
+            <a:schemeClr val="accent1"/>
+          </a:fillRef>
+          <a:effectRef idx="2">
+            <a:schemeClr val="accent1"/>
+          </a:effectRef>
+          <a:fontRef idx="minor">
+            <a:schemeClr val="lt1"/>
+          </a:fontRef>
+        </p:style>
+        <p:txBody>
+          <a:bodyPr rtlCol="0" anchor="ctr"/>
+          <a:lstStyle/>
+          <a:p>
+            <a:pPr algn="ctr"/>
+          </a:p>
+        </p:txBody>
+      </p:sp>
+      <p:sp>
+        <p:nvSpPr>
+          <p:cNvPr id="8" name="TextBox 7"/>
+          <p:cNvSpPr txBox="1"/>
+          <p:nvPr/>
+        </p:nvSpPr>
+        <p:spPr>
+          <a:xfrm>
+            <a:off x="777240" y="1664207"/>
+            <a:ext cx="6126480" cy="365760"/>
+          </a:xfrm>
+          <a:prstGeom prst="rect">
+            <a:avLst/>
+          </a:prstGeom>
+          <a:noFill/>
+        </p:spPr>
+        <p:txBody>
+          <a:bodyPr wrap="square" lIns="0" rIns="0" tIns="0" bIns="0" anchor="t">
+            <a:spAutoFit/>
+          </a:bodyPr>
+          <a:lstStyle/>
+          <a:p>
+            <a:pPr algn="l"/>
+            <a:r>
+              <a:rPr sz="1700" b="1" i="0">
+                <a:solidFill>
+                  <a:srgbClr val="FFBE3D"/>
+                </a:solidFill>
+                <a:latin typeface="Calibri"/>
+              </a:rPr>
+              <a:t>Autonomy is a tie</a:t>
+            </a:r>
+          </a:p>
+        </p:txBody>
+      </p:sp>
+      <p:sp>
+        <p:nvSpPr>
+          <p:cNvPr id="9" name="TextBox 8"/>
+          <p:cNvSpPr txBox="1"/>
+          <p:nvPr/>
+        </p:nvSpPr>
+        <p:spPr>
+          <a:xfrm>
+            <a:off x="777240" y="2057400"/>
+            <a:ext cx="6126480" cy="548640"/>
+          </a:xfrm>
+          <a:prstGeom prst="rect">
+            <a:avLst/>
+          </a:prstGeom>
+          <a:noFill/>
+        </p:spPr>
+        <p:txBody>
+          <a:bodyPr wrap="square" lIns="0" rIns="0" tIns="0" bIns="0" anchor="t">
+            <a:spAutoFit/>
+          </a:bodyPr>
+          <a:lstStyle/>
+          <a:p>
+            <a:pPr algn="l"/>
+            <a:r>
+              <a:rPr sz="1400" b="0" i="0">
+                <a:solidFill>
+                  <a:srgbClr val="FFFFFF"/>
+                </a:solidFill>
+                <a:latin typeface="Calibri"/>
+              </a:rPr>
+              <a:t>The plain agent also reaches 100% on safe cases. The gap is verified fixes and safety.</a:t>
+            </a:r>
+          </a:p>
+        </p:txBody>
+      </p:sp>
+      <p:sp>
+        <p:nvSpPr>
+          <p:cNvPr id="10" name="Rounded Rectangle 9"/>
+          <p:cNvSpPr/>
+          <p:nvPr/>
+        </p:nvSpPr>
+        <p:spPr>
+          <a:xfrm>
+            <a:off x="548640" y="2724912"/>
+            <a:ext cx="6583680" cy="1051560"/>
+          </a:xfrm>
+          <a:prstGeom prst="roundRect">
+            <a:avLst>
+              <a:gd name="adj" fmla="val 6000"/>
+            </a:avLst>
+          </a:prstGeom>
+          <a:solidFill>
+            <a:srgbClr val="0848AC"/>
+          </a:solidFill>
+          <a:ln w="12700">
+            <a:solidFill>
+              <a:srgbClr val="407BC7"/>
+            </a:solidFill>
+          </a:ln>
+          <a:effectLst/>
+        </p:spPr>
+        <p:style>
+          <a:lnRef idx="1">
+            <a:schemeClr val="accent1"/>
+          </a:lnRef>
+          <a:fillRef idx="3">
+            <a:schemeClr val="accent1"/>
+          </a:fillRef>
+          <a:effectRef idx="2">
+            <a:schemeClr val="accent1"/>
+          </a:effectRef>
+          <a:fontRef idx="minor">
+            <a:schemeClr val="lt1"/>
+          </a:fontRef>
+        </p:style>
+        <p:txBody>
+          <a:bodyPr rtlCol="0" anchor="ctr"/>
+          <a:lstStyle/>
+          <a:p>
+            <a:pPr algn="ctr"/>
+          </a:p>
+        </p:txBody>
+      </p:sp>
+      <p:sp>
+        <p:nvSpPr>
+          <p:cNvPr id="11" name="TextBox 10"/>
+          <p:cNvSpPr txBox="1"/>
+          <p:nvPr/>
+        </p:nvSpPr>
+        <p:spPr>
+          <a:xfrm>
+            <a:off x="777240" y="2834640"/>
+            <a:ext cx="6126480" cy="365760"/>
+          </a:xfrm>
+          <a:prstGeom prst="rect">
+            <a:avLst/>
+          </a:prstGeom>
+          <a:noFill/>
+        </p:spPr>
+        <p:txBody>
+          <a:bodyPr wrap="square" lIns="0" rIns="0" tIns="0" bIns="0" anchor="t">
+            <a:spAutoFit/>
+          </a:bodyPr>
+          <a:lstStyle/>
+          <a:p>
+            <a:pPr algn="l"/>
+            <a:r>
+              <a:rPr sz="1700" b="1" i="0">
+                <a:solidFill>
+                  <a:srgbClr val="FFBE3D"/>
+                </a:solidFill>
+                <a:latin typeface="Calibri"/>
+              </a:rPr>
+              <a:t>The plain agent is cheaper here</a:t>
+            </a:r>
+          </a:p>
+        </p:txBody>
+      </p:sp>
+      <p:sp>
+        <p:nvSpPr>
+          <p:cNvPr id="12" name="TextBox 11"/>
+          <p:cNvSpPr txBox="1"/>
+          <p:nvPr/>
+        </p:nvSpPr>
+        <p:spPr>
+          <a:xfrm>
+            <a:off x="777240" y="3227832"/>
+            <a:ext cx="6126480" cy="548640"/>
+          </a:xfrm>
+          <a:prstGeom prst="rect">
+            <a:avLst/>
+          </a:prstGeom>
+          <a:noFill/>
+        </p:spPr>
+        <p:txBody>
+          <a:bodyPr wrap="square" lIns="0" rIns="0" tIns="0" bIns="0" anchor="t">
+            <a:spAutoFit/>
+          </a:bodyPr>
+          <a:lstStyle/>
+          <a:p>
+            <a:pPr algn="l"/>
+            <a:r>
+              <a:rPr sz="1400" b="0" i="0">
+                <a:solidFill>
+                  <a:srgbClr val="FFFFFF"/>
+                </a:solidFill>
+                <a:latin typeface="Calibri"/>
+              </a:rPr>
+              <a:t>About ₹49 vs ₹55 per case in the modeled cost, and the answer flips in 16 of 36 assumption combinations.</a:t>
+            </a:r>
+          </a:p>
+        </p:txBody>
+      </p:sp>
+      <p:sp>
+        <p:nvSpPr>
+          <p:cNvPr id="13" name="Rounded Rectangle 12"/>
+          <p:cNvSpPr/>
+          <p:nvPr/>
+        </p:nvSpPr>
+        <p:spPr>
+          <a:xfrm>
+            <a:off x="548640" y="3895344"/>
+            <a:ext cx="6583680" cy="1051560"/>
+          </a:xfrm>
+          <a:prstGeom prst="roundRect">
+            <a:avLst>
+              <a:gd name="adj" fmla="val 6000"/>
+            </a:avLst>
+          </a:prstGeom>
+          <a:solidFill>
+            <a:srgbClr val="0848AC"/>
+          </a:solidFill>
+          <a:ln w="12700">
+            <a:solidFill>
+              <a:srgbClr val="407BC7"/>
+            </a:solidFill>
+          </a:ln>
+          <a:effectLst/>
+        </p:spPr>
+        <p:style>
+          <a:lnRef idx="1">
+            <a:schemeClr val="accent1"/>
+          </a:lnRef>
+          <a:fillRef idx="3">
+            <a:schemeClr val="accent1"/>
+          </a:fillRef>
+          <a:effectRef idx="2">
+            <a:schemeClr val="accent1"/>
+          </a:effectRef>
+          <a:fontRef idx="minor">
+            <a:schemeClr val="lt1"/>
+          </a:fontRef>
+        </p:style>
+        <p:txBody>
+          <a:bodyPr rtlCol="0" anchor="ctr"/>
+          <a:lstStyle/>
+          <a:p>
+            <a:pPr algn="ctr"/>
+          </a:p>
+        </p:txBody>
+      </p:sp>
+      <p:sp>
+        <p:nvSpPr>
+          <p:cNvPr id="14" name="TextBox 13"/>
+          <p:cNvSpPr txBox="1"/>
+          <p:nvPr/>
+        </p:nvSpPr>
+        <p:spPr>
+          <a:xfrm>
+            <a:off x="777240" y="4005072"/>
+            <a:ext cx="6126480" cy="365760"/>
+          </a:xfrm>
+          <a:prstGeom prst="rect">
+            <a:avLst/>
+          </a:prstGeom>
+          <a:noFill/>
+        </p:spPr>
+        <p:txBody>
+          <a:bodyPr wrap="square" lIns="0" rIns="0" tIns="0" bIns="0" anchor="t">
+            <a:spAutoFit/>
+          </a:bodyPr>
+          <a:lstStyle/>
+          <a:p>
+            <a:pPr algn="l"/>
+            <a:r>
+              <a:rPr sz="1700" b="1" i="0">
+                <a:solidFill>
+                  <a:srgbClr val="FFBE3D"/>
+                </a:solidFill>
+                <a:latin typeface="Calibri"/>
+              </a:rPr>
+              <a:t>The benchmark is self-authored</a:t>
+            </a:r>
+          </a:p>
+        </p:txBody>
+      </p:sp>
+      <p:sp>
+        <p:nvSpPr>
+          <p:cNvPr id="15" name="TextBox 14"/>
+          <p:cNvSpPr txBox="1"/>
+          <p:nvPr/>
+        </p:nvSpPr>
+        <p:spPr>
+          <a:xfrm>
+            <a:off x="777240" y="4398264"/>
+            <a:ext cx="6126480" cy="548640"/>
+          </a:xfrm>
+          <a:prstGeom prst="rect">
+            <a:avLst/>
+          </a:prstGeom>
+          <a:noFill/>
+        </p:spPr>
+        <p:txBody>
+          <a:bodyPr wrap="square" lIns="0" rIns="0" tIns="0" bIns="0" anchor="t">
+            <a:spAutoFit/>
+          </a:bodyPr>
+          <a:lstStyle/>
+          <a:p>
+            <a:pPr algn="l"/>
+            <a:r>
+              <a:rPr sz="1400" b="0" i="0">
+                <a:solidFill>
+                  <a:srgbClr val="FFFFFF"/>
+                </a:solidFill>
+                <a:latin typeface="Calibri"/>
+              </a:rPr>
+              <a:t>We wrote scenarios, ground truth and scorer. Independent scenarios are next.</a:t>
+            </a:r>
+          </a:p>
+        </p:txBody>
+      </p:sp>
+      <p:sp>
+        <p:nvSpPr>
+          <p:cNvPr id="16" name="Rounded Rectangle 15"/>
+          <p:cNvSpPr/>
+          <p:nvPr/>
+        </p:nvSpPr>
+        <p:spPr>
+          <a:xfrm>
+            <a:off x="548640" y="5065776"/>
+            <a:ext cx="6583680" cy="1051560"/>
+          </a:xfrm>
+          <a:prstGeom prst="roundRect">
+            <a:avLst>
+              <a:gd name="adj" fmla="val 6000"/>
+            </a:avLst>
+          </a:prstGeom>
+          <a:solidFill>
+            <a:srgbClr val="0848AC"/>
+          </a:solidFill>
+          <a:ln w="12700">
+            <a:solidFill>
+              <a:srgbClr val="407BC7"/>
+            </a:solidFill>
+          </a:ln>
+          <a:effectLst/>
+        </p:spPr>
+        <p:style>
+          <a:lnRef idx="1">
+            <a:schemeClr val="accent1"/>
+          </a:lnRef>
+          <a:fillRef idx="3">
+            <a:schemeClr val="accent1"/>
+          </a:fillRef>
+          <a:effectRef idx="2">
+            <a:schemeClr val="accent1"/>
+          </a:effectRef>
+          <a:fontRef idx="minor">
+            <a:schemeClr val="lt1"/>
+          </a:fontRef>
+        </p:style>
+        <p:txBody>
+          <a:bodyPr rtlCol="0" anchor="ctr"/>
+          <a:lstStyle/>
+          <a:p>
+            <a:pPr algn="ctr"/>
+          </a:p>
+        </p:txBody>
+      </p:sp>
+      <p:sp>
+        <p:nvSpPr>
+          <p:cNvPr id="17" name="TextBox 16"/>
+          <p:cNvSpPr txBox="1"/>
+          <p:nvPr/>
+        </p:nvSpPr>
+        <p:spPr>
+          <a:xfrm>
+            <a:off x="777240" y="5175504"/>
+            <a:ext cx="6126480" cy="365760"/>
+          </a:xfrm>
+          <a:prstGeom prst="rect">
+            <a:avLst/>
+          </a:prstGeom>
+          <a:noFill/>
+        </p:spPr>
+        <p:txBody>
+          <a:bodyPr wrap="square" lIns="0" rIns="0" tIns="0" bIns="0" anchor="t">
+            <a:spAutoFit/>
+          </a:bodyPr>
+          <a:lstStyle/>
+          <a:p>
+            <a:pPr algn="l"/>
+            <a:r>
+              <a:rPr sz="1700" b="1" i="0">
+                <a:solidFill>
+                  <a:srgbClr val="FFBE3D"/>
+                </a:solidFill>
+                <a:latin typeface="Calibri"/>
+              </a:rPr>
+              <a:t>Understanding is imperfect</a:t>
+            </a:r>
+          </a:p>
+        </p:txBody>
+      </p:sp>
+      <p:sp>
+        <p:nvSpPr>
+          <p:cNvPr id="18" name="TextBox 17"/>
+          <p:cNvSpPr txBox="1"/>
+          <p:nvPr/>
+        </p:nvSpPr>
+        <p:spPr>
+          <a:xfrm>
+            <a:off x="777240" y="5568696"/>
+            <a:ext cx="6126480" cy="548640"/>
+          </a:xfrm>
+          <a:prstGeom prst="rect">
+            <a:avLst/>
+          </a:prstGeom>
+          <a:noFill/>
+        </p:spPr>
+        <p:txBody>
+          <a:bodyPr wrap="square" lIns="0" rIns="0" tIns="0" bIns="0" anchor="t">
+            <a:spAutoFit/>
+          </a:bodyPr>
+          <a:lstStyle/>
+          <a:p>
+            <a:pPr algn="l"/>
+            <a:r>
+              <a:rPr sz="1400" b="0" i="0">
+                <a:solidFill>
+                  <a:srgbClr val="FFFFFF"/>
+                </a:solidFill>
+                <a:latin typeface="Calibri"/>
+              </a:rPr>
+              <a:t>Intent right 80% on 120 labelled messages; 5 of 14 forbidden asks missed, none unsafe.</a:t>
+            </a:r>
+          </a:p>
+        </p:txBody>
+      </p:sp>
+      <p:sp>
+        <p:nvSpPr>
+          <p:cNvPr id="19" name="Rounded Rectangle 18"/>
+          <p:cNvSpPr/>
+          <p:nvPr/>
+        </p:nvSpPr>
+        <p:spPr>
+          <a:xfrm>
+            <a:off x="7406640" y="1554480"/>
+            <a:ext cx="4206240" cy="4572000"/>
+          </a:xfrm>
+          <a:prstGeom prst="roundRect">
+            <a:avLst>
+              <a:gd name="adj" fmla="val 6000"/>
+            </a:avLst>
+          </a:prstGeom>
+          <a:solidFill>
+            <a:srgbClr val="0848AC"/>
+          </a:solidFill>
+          <a:ln w="12700">
+            <a:solidFill>
+              <a:srgbClr val="407BC7"/>
+            </a:solidFill>
+          </a:ln>
+          <a:effectLst/>
+        </p:spPr>
+        <p:style>
+          <a:lnRef idx="1">
+            <a:schemeClr val="accent1"/>
+          </a:lnRef>
+          <a:fillRef idx="3">
+            <a:schemeClr val="accent1"/>
+          </a:fillRef>
+          <a:effectRef idx="2">
+            <a:schemeClr val="accent1"/>
+          </a:effectRef>
+          <a:fontRef idx="minor">
+            <a:schemeClr val="lt1"/>
+          </a:fontRef>
+        </p:style>
+        <p:txBody>
+          <a:bodyPr rtlCol="0" anchor="ctr"/>
+          <a:lstStyle/>
+          <a:p>
+            <a:pPr algn="ctr"/>
+          </a:p>
+        </p:txBody>
+      </p:sp>
+      <p:sp>
+        <p:nvSpPr>
           <p:cNvPr id="20" name="TextBox 19"/>
           <p:cNvSpPr txBox="1"/>
           <p:nvPr/>
@@ -6656,7 +8243,7 @@
               </a:spcAft>
             </a:pPr>
             <a:r>
-              <a:rPr sz="1500" b="0" i="0">
+              <a:rPr sz="1400" b="0" i="0">
                 <a:solidFill>
                   <a:srgbClr val="FFFFFF"/>
                 </a:solidFill>
@@ -6672,13 +8259,13 @@
               </a:spcAft>
             </a:pPr>
             <a:r>
-              <a:rPr sz="1500" b="0" i="0">
+              <a:rPr sz="1400" b="0" i="0">
                 <a:solidFill>
                   <a:srgbClr val="FFFFFF"/>
                 </a:solidFill>
                 <a:latin typeface="Calibri"/>
               </a:rPr>
-              <a:t>2.  Independent scenarios, and more templates (the spec asks for 40; we have 14 families)</a:t>
+              <a:t>2.  Independent scenarios (our hand-written set has the same author) and more templates</a:t>
             </a:r>
           </a:p>
           <a:p>
@@ -6688,7 +8275,7 @@
               </a:spcAft>
             </a:pPr>
             <a:r>
-              <a:rPr sz="1500" b="0" i="0">
+              <a:rPr sz="1400" b="0" i="0">
                 <a:solidFill>
                   <a:srgbClr val="FFFFFF"/>
                 </a:solidFill>
@@ -6704,13 +8291,13 @@
               </a:spcAft>
             </a:pPr>
             <a:r>
-              <a:rPr sz="1500" b="0" i="0">
+              <a:rPr sz="1400" b="0" i="0">
                 <a:solidFill>
                   <a:srgbClr val="FFFFFF"/>
                 </a:solidFill>
                 <a:latin typeface="Calibri"/>
               </a:rPr>
-              <a:t>4.  A pre-declared escalation-recall target</a:t>
+              <a:t>4.  Feed measured action effects back into the engine</a:t>
             </a:r>
           </a:p>
           <a:p>
@@ -6726,7 +8313,7 @@
                 </a:solidFill>
                 <a:latin typeface="Calibri"/>
               </a:rPr>
-              <a:t>Built since the first freeze: promise ledger, portfolio view (illustrative), Hindi voice in the browser, sensitivity analysis.</a:t>
+              <a:t>Simulated, not real: the Soundbox, the lender behind bridge offers, the debtors, all merchants and money.</a:t>
             </a:r>
           </a:p>
           <a:p>
@@ -6742,7 +8329,7 @@
                 </a:solidFill>
                 <a:latin typeface="Calibri"/>
               </a:rPr>
-              <a:t>Future work, not built: bridge financing, udhaar recovery, learned rules, Soundbox hardware.</a:t>
+              <a:t>Not met: escalation-recall target for the main benchmark was never pre-declared; override rate is too noisy to call falling.</a:t>
             </a:r>
           </a:p>
         </p:txBody>
@@ -6854,7 +8441,7 @@
                 </a:solidFill>
                 <a:latin typeface="Calibri"/>
               </a:rPr>
-              <a:t>02 / 11</a:t>
+              <a:t>02 / 12</a:t>
             </a:r>
           </a:p>
         </p:txBody>
@@ -7908,7 +9495,7 @@
                 </a:solidFill>
                 <a:latin typeface="Calibri"/>
               </a:rPr>
-              <a:t>03 / 11</a:t>
+              <a:t>03 / 12</a:t>
             </a:r>
           </a:p>
         </p:txBody>
@@ -8590,7 +10177,7 @@
                 </a:solidFill>
                 <a:latin typeface="Calibri"/>
               </a:rPr>
-              <a:t>04 / 11</a:t>
+              <a:t>04 / 12</a:t>
             </a:r>
           </a:p>
         </p:txBody>
@@ -9365,7 +10952,7 @@
                 </a:solidFill>
                 <a:latin typeface="Calibri"/>
               </a:rPr>
-              <a:t>05 / 11</a:t>
+              <a:t>05 / 12</a:t>
             </a:r>
           </a:p>
         </p:txBody>
@@ -10221,7 +11808,7 @@
                 </a:solidFill>
                 <a:latin typeface="Calibri"/>
               </a:rPr>
-              <a:t>06 / 11</a:t>
+              <a:t>06 / 12</a:t>
             </a:r>
           </a:p>
         </p:txBody>
@@ -11156,7 +12743,7 @@
                 </a:solidFill>
                 <a:latin typeface="Calibri"/>
               </a:rPr>
-              <a:t>• Encrypted, tamper-evident audit log; kill switch</a:t>
+              <a:t>• Learned rules: an analyst confirms each one; narrow, capped, never Tier 4</a:t>
             </a:r>
           </a:p>
         </p:txBody>
@@ -11268,7 +12855,7 @@
                 </a:solidFill>
                 <a:latin typeface="Calibri"/>
               </a:rPr>
-              <a:t>07 / 11</a:t>
+              <a:t>07 / 12</a:t>
             </a:r>
           </a:p>
         </p:txBody>
@@ -12241,7 +13828,7 @@
                 </a:solidFill>
                 <a:latin typeface="Calibri"/>
               </a:rPr>
-              <a:t>08 / 11</a:t>
+              <a:t>08 / 12</a:t>
             </a:r>
           </a:p>
         </p:txBody>
@@ -12930,7 +14517,7 @@
                 </a:solidFill>
                 <a:latin typeface="Calibri"/>
               </a:rPr>
-              <a:t>09 / 11</a:t>
+              <a:t>09 / 12</a:t>
             </a:r>
           </a:p>
         </p:txBody>

</xml_diff>